<commit_message>
Presentation and Code Review
</commit_message>
<xml_diff>
--- a/Apresentação.pptx
+++ b/Apresentação.pptx
@@ -14186,7 +14186,7 @@
                 </a:solidFill>
                 <a:latin typeface="Raleway Medium"/>
               </a:rPr>
-              <a:t> (11.280 </a:t>
+              <a:t> /11.280 </a:t>
             </a:r>
             <a:r>
               <a:rPr lang="en-US" sz="1400" dirty="0" err="1">
@@ -14197,16 +14197,34 @@
               </a:rPr>
               <a:t>Validação</a:t>
             </a:r>
-            <a:r>
-              <a:rPr lang="en-US" sz="1400" dirty="0">
+            <a:endParaRPr lang="en-US" sz="1400" dirty="0">
+              <a:solidFill>
+                <a:schemeClr val="dk1"/>
+              </a:solidFill>
+              <a:latin typeface="Raleway Medium"/>
+            </a:endParaRPr>
+          </a:p>
+          <a:p>
+            <a:pPr marL="285750" indent="-285750" algn="just">
+              <a:lnSpc>
+                <a:spcPct val="150000"/>
+              </a:lnSpc>
+              <a:buFont typeface="Arial" panose="020B0604020202020204" pitchFamily="34" charset="0"/>
+              <a:buChar char="•"/>
+              <a:tabLst>
+                <a:tab pos="0" algn="l"/>
+              </a:tabLst>
+            </a:pPr>
+            <a:r>
+              <a:rPr lang="en-US" sz="1400" b="1" dirty="0">
                 <a:solidFill>
                   <a:schemeClr val="dk1"/>
                 </a:solidFill>
                 <a:latin typeface="Raleway Medium"/>
               </a:rPr>
-              <a:t>)/18.800 Teste</a:t>
-            </a:r>
-            <a:endParaRPr lang="en-US" sz="1400" b="0" u="none" strike="noStrike" dirty="0">
+              <a:t>18.800 para Teste</a:t>
+            </a:r>
+            <a:endParaRPr lang="en-US" sz="1400" b="1" u="none" strike="noStrike" dirty="0">
               <a:solidFill>
                 <a:srgbClr val="FFFFFF"/>
               </a:solidFill>
@@ -14245,7 +14263,7 @@
         </p:blipFill>
         <p:spPr>
           <a:xfrm>
-            <a:off x="705126" y="2906088"/>
+            <a:off x="705126" y="3021235"/>
             <a:ext cx="7733748" cy="1848785"/>
           </a:xfrm>
           <a:prstGeom prst="rect">

</xml_diff>